<commit_message>
fix: update presentation with real team names and sequential section numbering
- Replace all Lead/M2/M3/M4/M5 placeholders with actual names (Khizar/Mustafa/Hammad/Ammar/Anas)
- Fix section numbering to be sequential (1-18)
- Rebuild presentation file (20 slides)
</commit_message>
<xml_diff>
--- a/presentation/Agent01_Pitch_Deck.pptx
+++ b/presentation/Agent01_Pitch_Deck.pptx
@@ -3504,7 +3504,7 @@
               </a:defRPr>
             </a:pPr>
             <a:r>
-              <a:t>Team:  Lead  •  M2  •  M3  •  M4  •  M5</a:t>
+              <a:t>Team:  Khizar  •  Mustafa  •  Hammad  •  Ammar  •  Anas</a:t>
             </a:r>
           </a:p>
         </p:txBody>
@@ -5859,7 +5859,7 @@
               </a:defRPr>
             </a:pPr>
             <a:r>
-              <a:t>8</a:t>
+              <a:t>10</a:t>
             </a:r>
           </a:p>
         </p:txBody>
@@ -6091,7 +6091,7 @@
               </a:defRPr>
             </a:pPr>
             <a:r>
-              <a:t>  M5</a:t>
+              <a:t>  Anas</a:t>
             </a:r>
           </a:p>
         </p:txBody>
@@ -6474,7 +6474,7 @@
               </a:defRPr>
             </a:pPr>
             <a:r>
-              <a:t>  M5</a:t>
+              <a:t>  Anas</a:t>
             </a:r>
           </a:p>
         </p:txBody>
@@ -6893,7 +6893,7 @@
               </a:defRPr>
             </a:pPr>
             <a:r>
-              <a:t>  M5</a:t>
+              <a:t>  Anas</a:t>
             </a:r>
           </a:p>
         </p:txBody>
@@ -7312,7 +7312,7 @@
               </a:defRPr>
             </a:pPr>
             <a:r>
-              <a:t>  M5</a:t>
+              <a:t>  Anas</a:t>
             </a:r>
           </a:p>
         </p:txBody>
@@ -7763,7 +7763,7 @@
               </a:defRPr>
             </a:pPr>
             <a:r>
-              <a:t>9</a:t>
+              <a:t>11</a:t>
             </a:r>
           </a:p>
         </p:txBody>
@@ -7907,7 +7907,7 @@
               </a:defRPr>
             </a:pPr>
             <a:r>
-              <a:t>M2</a:t>
+              <a:t>Mustafa</a:t>
             </a:r>
           </a:p>
         </p:txBody>
@@ -8101,7 +8101,7 @@
               </a:defRPr>
             </a:pPr>
             <a:r>
-              <a:t>M3</a:t>
+              <a:t>Hammad</a:t>
             </a:r>
           </a:p>
         </p:txBody>
@@ -8295,7 +8295,7 @@
               </a:defRPr>
             </a:pPr>
             <a:r>
-              <a:t>Lead</a:t>
+              <a:t>Khizar</a:t>
             </a:r>
           </a:p>
         </p:txBody>
@@ -8489,7 +8489,7 @@
               </a:defRPr>
             </a:pPr>
             <a:r>
-              <a:t>M4</a:t>
+              <a:t>Ammar</a:t>
             </a:r>
           </a:p>
         </p:txBody>
@@ -8683,7 +8683,7 @@
               </a:defRPr>
             </a:pPr>
             <a:r>
-              <a:t>M5</a:t>
+              <a:t>Anas</a:t>
             </a:r>
           </a:p>
         </p:txBody>
@@ -9545,7 +9545,7 @@
               </a:defRPr>
             </a:pPr>
             <a:r>
-              <a:t>10</a:t>
+              <a:t>12</a:t>
             </a:r>
           </a:p>
         </p:txBody>
@@ -12745,7 +12745,7 @@
               </a:defRPr>
             </a:pPr>
             <a:r>
-              <a:t>12</a:t>
+              <a:t>14</a:t>
             </a:r>
           </a:p>
         </p:txBody>
@@ -15230,7 +15230,7 @@
               </a:defRPr>
             </a:pPr>
             <a:r>
-              <a:t>13</a:t>
+              <a:t>15</a:t>
             </a:r>
           </a:p>
         </p:txBody>
@@ -17139,7 +17139,7 @@
               </a:defRPr>
             </a:pPr>
             <a:r>
-              <a:t>15</a:t>
+              <a:t>16</a:t>
             </a:r>
           </a:p>
         </p:txBody>
@@ -18972,7 +18972,7 @@
               </a:defRPr>
             </a:pPr>
             <a:r>
-              <a:t>14</a:t>
+              <a:t>17</a:t>
             </a:r>
           </a:p>
         </p:txBody>
@@ -23868,7 +23868,7 @@
               </a:defRPr>
             </a:pPr>
             <a:r>
-              <a:t>15</a:t>
+              <a:t>18</a:t>
             </a:r>
           </a:p>
         </p:txBody>
@@ -26346,7 +26346,7 @@
               </a:defRPr>
             </a:pPr>
             <a:r>
-              <a:t>L</a:t>
+              <a:t>K</a:t>
             </a:r>
           </a:p>
         </p:txBody>
@@ -26382,7 +26382,7 @@
               </a:defRPr>
             </a:pPr>
             <a:r>
-              <a:t>Lead</a:t>
+              <a:t>Khizar</a:t>
             </a:r>
           </a:p>
         </p:txBody>
@@ -26497,7 +26497,7 @@
               </a:defRPr>
             </a:pPr>
             <a:r>
-              <a:t>M2</a:t>
+              <a:t>Mustafa</a:t>
             </a:r>
           </a:p>
         </p:txBody>
@@ -26576,7 +26576,7 @@
               </a:defRPr>
             </a:pPr>
             <a:r>
-              <a:t>M</a:t>
+              <a:t>H</a:t>
             </a:r>
           </a:p>
         </p:txBody>
@@ -26612,7 +26612,7 @@
               </a:defRPr>
             </a:pPr>
             <a:r>
-              <a:t>M3</a:t>
+              <a:t>Hammad</a:t>
             </a:r>
           </a:p>
         </p:txBody>
@@ -26691,7 +26691,7 @@
               </a:defRPr>
             </a:pPr>
             <a:r>
-              <a:t>M</a:t>
+              <a:t>A</a:t>
             </a:r>
           </a:p>
         </p:txBody>
@@ -26727,7 +26727,7 @@
               </a:defRPr>
             </a:pPr>
             <a:r>
-              <a:t>M4</a:t>
+              <a:t>Ammar</a:t>
             </a:r>
           </a:p>
         </p:txBody>
@@ -26806,7 +26806,7 @@
               </a:defRPr>
             </a:pPr>
             <a:r>
-              <a:t>M</a:t>
+              <a:t>A</a:t>
             </a:r>
           </a:p>
         </p:txBody>
@@ -26842,7 +26842,7 @@
               </a:defRPr>
             </a:pPr>
             <a:r>
-              <a:t>M5</a:t>
+              <a:t>Anas</a:t>
             </a:r>
           </a:p>
         </p:txBody>
@@ -29412,7 +29412,7 @@
               </a:defRPr>
             </a:pPr>
             <a:r>
-              <a:t>2</a:t>
+              <a:t>3</a:t>
             </a:r>
           </a:p>
         </p:txBody>
@@ -30542,7 +30542,7 @@
               </a:defRPr>
             </a:pPr>
             <a:r>
-              <a:t>3</a:t>
+              <a:t>4</a:t>
             </a:r>
           </a:p>
         </p:txBody>
@@ -33093,7 +33093,7 @@
               </a:defRPr>
             </a:pPr>
             <a:r>
-              <a:t>4</a:t>
+              <a:t>6</a:t>
             </a:r>
           </a:p>
         </p:txBody>
@@ -33891,7 +33891,7 @@
               </a:defRPr>
             </a:pPr>
             <a:r>
-              <a:t>5</a:t>
+              <a:t>7</a:t>
             </a:r>
           </a:p>
         </p:txBody>
@@ -34087,7 +34087,7 @@
               </a:defRPr>
             </a:pPr>
             <a:r>
-              <a:t>Lead</a:t>
+              <a:t>Khizar</a:t>
             </a:r>
           </a:p>
         </p:txBody>
@@ -34503,7 +34503,7 @@
               </a:defRPr>
             </a:pPr>
             <a:r>
-              <a:t>M2</a:t>
+              <a:t>Mustafa</a:t>
             </a:r>
           </a:p>
         </p:txBody>
@@ -34919,7 +34919,7 @@
               </a:defRPr>
             </a:pPr>
             <a:r>
-              <a:t>M3</a:t>
+              <a:t>Hammad</a:t>
             </a:r>
           </a:p>
         </p:txBody>
@@ -35335,7 +35335,7 @@
               </a:defRPr>
             </a:pPr>
             <a:r>
-              <a:t>M4</a:t>
+              <a:t>Ammar</a:t>
             </a:r>
           </a:p>
         </p:txBody>
@@ -35751,7 +35751,7 @@
               </a:defRPr>
             </a:pPr>
             <a:r>
-              <a:t>M5</a:t>
+              <a:t>Anas</a:t>
             </a:r>
           </a:p>
         </p:txBody>
@@ -36866,7 +36866,7 @@
               </a:defRPr>
             </a:pPr>
             <a:r>
-              <a:t>Lead</a:t>
+              <a:t>Khizar</a:t>
             </a:r>
           </a:p>
         </p:txBody>
@@ -37283,7 +37283,7 @@
               </a:defRPr>
             </a:pPr>
             <a:r>
-              <a:t>M2</a:t>
+              <a:t>Mustafa</a:t>
             </a:r>
           </a:p>
         </p:txBody>
@@ -37700,7 +37700,7 @@
               </a:defRPr>
             </a:pPr>
             <a:r>
-              <a:t>M3</a:t>
+              <a:t>Hammad</a:t>
             </a:r>
           </a:p>
         </p:txBody>
@@ -38121,7 +38121,7 @@
               </a:defRPr>
             </a:pPr>
             <a:r>
-              <a:t>Lead</a:t>
+              <a:t>Khizar</a:t>
             </a:r>
           </a:p>
         </p:txBody>
@@ -38534,7 +38534,7 @@
               </a:defRPr>
             </a:pPr>
             <a:r>
-              <a:t>M4</a:t>
+              <a:t>Ammar</a:t>
             </a:r>
           </a:p>
         </p:txBody>
@@ -38947,7 +38947,7 @@
               </a:defRPr>
             </a:pPr>
             <a:r>
-              <a:t>M4</a:t>
+              <a:t>Ammar</a:t>
             </a:r>
           </a:p>
         </p:txBody>

</xml_diff>